<commit_message>
Revise emulator section of land-use documentation for the global model
</commit_message>
<xml_diff>
--- a/doc/_static/png_source_files/Land-use_emulator_RES.pptx
+++ b/doc/_static/png_source_files/Land-use_emulator_RES.pptx
@@ -5781,6 +5781,7 @@
             <a:solidFill>
               <a:schemeClr val="accent2"/>
             </a:solidFill>
+            <a:prstDash val="dash"/>
             <a:tailEnd type="triangle"/>
           </a:ln>
         </p:spPr>
@@ -6006,7 +6007,7 @@
           </a:prstGeom>
           <a:ln w="28575">
             <a:solidFill>
-              <a:srgbClr val="336600"/>
+              <a:srgbClr val="7F7F7F"/>
             </a:solidFill>
           </a:ln>
         </p:spPr>
@@ -6196,7 +6197,7 @@
           </a:prstGeom>
           <a:ln w="28575">
             <a:solidFill>
-              <a:srgbClr val="336600"/>
+              <a:srgbClr val="7F7F7F"/>
             </a:solidFill>
             <a:tailEnd type="triangle"/>
           </a:ln>
@@ -6282,14 +6283,14 @@
           <a:noFill/>
         </p:spPr>
         <p:txBody>
-          <a:bodyPr wrap="square" rtlCol="0">
+          <a:bodyPr wrap="none" rtlCol="0">
             <a:spAutoFit/>
           </a:bodyPr>
           <a:lstStyle/>
           <a:p>
             <a:r>
               <a:rPr lang="en-US" sz="1600" dirty="0"/>
-              <a:t>biomass (Link) </a:t>
+              <a:t>Biomass (link)</a:t>
             </a:r>
             <a:endParaRPr lang="en-GB" sz="1600" dirty="0"/>
           </a:p>
@@ -6409,6 +6410,7 @@
             <a:solidFill>
               <a:schemeClr val="accent2"/>
             </a:solidFill>
+            <a:prstDash val="dash"/>
           </a:ln>
         </p:spPr>
         <p:style>
@@ -6452,6 +6454,7 @@
             <a:solidFill>
               <a:schemeClr val="accent2"/>
             </a:solidFill>
+            <a:prstDash val="dash"/>
             <a:tailEnd type="triangle"/>
           </a:ln>
         </p:spPr>
@@ -6533,6 +6536,7 @@
             <a:solidFill>
               <a:schemeClr val="accent2"/>
             </a:solidFill>
+            <a:prstDash val="dash"/>
             <a:tailEnd type="none"/>
           </a:ln>
         </p:spPr>
@@ -6619,8 +6623,8 @@
         </p:nvCxnSpPr>
         <p:spPr>
           <a:xfrm flipV="1">
-            <a:off x="3299544" y="2600394"/>
-            <a:ext cx="4534356" cy="23234"/>
+            <a:off x="3819651" y="2600394"/>
+            <a:ext cx="4014249" cy="23234"/>
           </a:xfrm>
           <a:prstGeom prst="straightConnector1">
             <a:avLst/>
@@ -6629,6 +6633,7 @@
             <a:solidFill>
               <a:schemeClr val="accent2"/>
             </a:solidFill>
+            <a:prstDash val="dash"/>
             <a:tailEnd type="triangle"/>
           </a:ln>
         </p:spPr>
@@ -6905,7 +6910,7 @@
           </a:prstGeom>
           <a:ln w="28575">
             <a:solidFill>
-              <a:srgbClr val="336600"/>
+              <a:srgbClr val="7F7F7F"/>
             </a:solidFill>
             <a:tailEnd type="triangle"/>
           </a:ln>
@@ -6995,6 +7000,7 @@
             <a:solidFill>
               <a:schemeClr val="accent2"/>
             </a:solidFill>
+            <a:prstDash val="dash"/>
           </a:ln>
         </p:spPr>
         <p:style>
@@ -7038,6 +7044,7 @@
             <a:solidFill>
               <a:schemeClr val="accent2"/>
             </a:solidFill>
+            <a:prstDash val="dash"/>
             <a:tailEnd type="triangle"/>
           </a:ln>
         </p:spPr>
@@ -7082,6 +7089,7 @@
             <a:solidFill>
               <a:schemeClr val="accent2"/>
             </a:solidFill>
+            <a:prstDash val="dash"/>
             <a:tailEnd type="triangle"/>
           </a:ln>
         </p:spPr>
@@ -7126,6 +7134,7 @@
             <a:solidFill>
               <a:schemeClr val="accent2"/>
             </a:solidFill>
+            <a:prstDash val="dash"/>
             <a:tailEnd type="triangle"/>
           </a:ln>
         </p:spPr>
@@ -7170,6 +7179,7 @@
             <a:solidFill>
               <a:schemeClr val="accent2"/>
             </a:solidFill>
+            <a:prstDash val="dash"/>
             <a:tailEnd type="triangle"/>
           </a:ln>
         </p:spPr>
@@ -7211,14 +7221,14 @@
           <a:noFill/>
         </p:spPr>
         <p:txBody>
-          <a:bodyPr wrap="square" rtlCol="0">
+          <a:bodyPr wrap="none" rtlCol="0">
             <a:spAutoFit/>
           </a:bodyPr>
           <a:lstStyle/>
           <a:p>
             <a:r>
               <a:rPr lang="en-US" sz="1600" dirty="0"/>
-              <a:t>Energy System-GHG-emissions </a:t>
+              <a:t>Energy-system GHG emissions</a:t>
             </a:r>
             <a:endParaRPr lang="en-GB" sz="1600" dirty="0"/>
           </a:p>
@@ -7390,6 +7400,7 @@
             <a:solidFill>
               <a:schemeClr val="accent2"/>
             </a:solidFill>
+            <a:prstDash val="dash"/>
             <a:tailEnd type="triangle"/>
           </a:ln>
         </p:spPr>
@@ -7615,7 +7626,7 @@
             <a:pPr algn="ctr"/>
             <a:r>
               <a:rPr lang="en-US" dirty="0"/>
-              <a:t>BIO06GHG2000</a:t>
+              <a:t>BIO60GHG3000</a:t>
             </a:r>
             <a:endParaRPr lang="en-GB" dirty="0"/>
           </a:p>
@@ -7635,8 +7646,8 @@
         </p:nvSpPr>
         <p:spPr>
           <a:xfrm rot="16200000" flipH="1">
-            <a:off x="2475172" y="5087455"/>
-            <a:ext cx="2476877" cy="338554"/>
+            <a:off x="2903985" y="5383798"/>
+            <a:ext cx="1619250" cy="338554"/>
           </a:xfrm>
           <a:prstGeom prst="rect">
             <a:avLst/>
@@ -7644,14 +7655,14 @@
           <a:noFill/>
         </p:spPr>
         <p:txBody>
-          <a:bodyPr wrap="square" rtlCol="0">
+          <a:bodyPr wrap="none" rtlCol="0">
             <a:spAutoFit/>
           </a:bodyPr>
           <a:lstStyle/>
           <a:p>
             <a:r>
               <a:rPr lang="en-US" sz="1600" dirty="0"/>
-              <a:t>LU-GHG-emissions (Link) </a:t>
+              <a:t>Land-use emissions</a:t>
             </a:r>
             <a:endParaRPr lang="en-GB" sz="1600" dirty="0"/>
           </a:p>
@@ -7678,8 +7689,13 @@
             <a:avLst/>
           </a:prstGeom>
           <a:solidFill>
-            <a:srgbClr val="336600"/>
+            <a:srgbClr val="7F7F7F"/>
           </a:solidFill>
+          <a:ln>
+            <a:solidFill>
+              <a:srgbClr val="7F7F7F"/>
+            </a:solidFill>
+          </a:ln>
           <a:effectLst>
             <a:outerShdw blurRad="50800" dist="38100" dir="2700000" algn="tl" rotWithShape="0">
               <a:prstClr val="black">
@@ -7712,6 +7728,467 @@
             <a:r>
               <a:rPr lang="en-US" dirty="0"/>
               <a:t>coal resource</a:t>
+            </a:r>
+          </a:p>
+        </p:txBody>
+      </p:sp>
+      <p:sp>
+        <p:nvSpPr>
+          <p:cNvPr id="121" name="TextBox 120"/>
+          <p:cNvSpPr txBox="1"/>
+          <p:nvPr/>
+        </p:nvSpPr>
+        <p:spPr>
+          <a:xfrm>
+            <a:off x="571500" y="5334000"/>
+            <a:ext cx="2476500" cy="285750"/>
+          </a:xfrm>
+          <a:prstGeom prst="rect">
+            <a:avLst/>
+          </a:prstGeom>
+          <a:noFill/>
+        </p:spPr>
+        <p:txBody>
+          <a:bodyPr wrap="none">
+            <a:spAutoFit/>
+          </a:bodyPr>
+          <a:lstStyle/>
+          <a:p>
+            <a:r>
+              <a:rPr sz="1400" i="1">
+                <a:solidFill>
+                  <a:srgbClr val="404040"/>
+                </a:solidFill>
+              </a:rPr>
+              <a:t>Land-use emulator</a:t>
+            </a:r>
+          </a:p>
+          <a:p>
+            <a:r>
+              <a:rPr sz="1400" i="1">
+                <a:solidFill>
+                  <a:srgbClr val="404040"/>
+                </a:solidFill>
+              </a:rPr>
+              <a:t>(GLOBIOM matrix)</a:t>
+            </a:r>
+          </a:p>
+        </p:txBody>
+      </p:sp>
+      <p:sp>
+        <p:nvSpPr>
+          <p:cNvPr id="122" name="TextBox 121"/>
+          <p:cNvSpPr txBox="1"/>
+          <p:nvPr/>
+        </p:nvSpPr>
+        <p:spPr>
+          <a:xfrm>
+            <a:off x="4152900" y="1447800"/>
+            <a:ext cx="2857500" cy="285750"/>
+          </a:xfrm>
+          <a:prstGeom prst="rect">
+            <a:avLst/>
+          </a:prstGeom>
+          <a:noFill/>
+        </p:spPr>
+        <p:txBody>
+          <a:bodyPr wrap="none">
+            <a:spAutoFit/>
+          </a:bodyPr>
+          <a:lstStyle/>
+          <a:p>
+            <a:r>
+              <a:rPr sz="1400" i="1">
+                <a:solidFill>
+                  <a:srgbClr val="404040"/>
+                </a:solidFill>
+              </a:rPr>
+              <a:t>Energy system (MESSAGEix)</a:t>
+            </a:r>
+          </a:p>
+        </p:txBody>
+      </p:sp>
+      <p:cxnSp>
+        <p:nvCxnSpPr>
+          <p:cNvPr id="123" name="Connector 122"/>
+          <p:cNvCxnSpPr/>
+          <p:nvPr/>
+        </p:nvCxnSpPr>
+        <p:spPr>
+          <a:xfrm>
+            <a:off x="1143000" y="1028700"/>
+            <a:ext cx="4572000" cy="0"/>
+          </a:xfrm>
+          <a:prstGeom prst="line">
+            <a:avLst/>
+          </a:prstGeom>
+          <a:ln w="28575">
+            <a:solidFill>
+              <a:srgbClr val="7030A0"/>
+            </a:solidFill>
+            <a:prstDash val="dash"/>
+          </a:ln>
+        </p:spPr>
+        <p:style>
+          <a:lnRef idx="2">
+            <a:schemeClr val="accent1"/>
+          </a:lnRef>
+          <a:fillRef idx="0">
+            <a:schemeClr val="accent1"/>
+          </a:fillRef>
+          <a:effectRef idx="1">
+            <a:schemeClr val="accent1"/>
+          </a:effectRef>
+          <a:fontRef idx="minor">
+            <a:schemeClr val="tx1"/>
+          </a:fontRef>
+        </p:style>
+      </p:cxnSp>
+      <p:cxnSp>
+        <p:nvCxnSpPr>
+          <p:cNvPr id="124" name="Connector 123"/>
+          <p:cNvCxnSpPr/>
+          <p:nvPr/>
+        </p:nvCxnSpPr>
+        <p:spPr>
+          <a:xfrm flipV="1">
+            <a:off x="1524000" y="1047750"/>
+            <a:ext cx="0" cy="361950"/>
+          </a:xfrm>
+          <a:prstGeom prst="line">
+            <a:avLst/>
+          </a:prstGeom>
+          <a:ln w="28575">
+            <a:solidFill>
+              <a:srgbClr val="7030A0"/>
+            </a:solidFill>
+            <a:prstDash val="dash"/>
+            <a:tailEnd type="triangle"/>
+          </a:ln>
+        </p:spPr>
+        <p:style>
+          <a:lnRef idx="2">
+            <a:schemeClr val="accent1"/>
+          </a:lnRef>
+          <a:fillRef idx="0">
+            <a:schemeClr val="accent1"/>
+          </a:fillRef>
+          <a:effectRef idx="1">
+            <a:schemeClr val="accent1"/>
+          </a:effectRef>
+          <a:fontRef idx="minor">
+            <a:schemeClr val="tx1"/>
+          </a:fontRef>
+        </p:style>
+      </p:cxnSp>
+      <p:cxnSp>
+        <p:nvCxnSpPr>
+          <p:cNvPr id="125" name="Connector 124"/>
+          <p:cNvCxnSpPr/>
+          <p:nvPr/>
+        </p:nvCxnSpPr>
+        <p:spPr>
+          <a:xfrm flipV="1">
+            <a:off x="5334000" y="1047750"/>
+            <a:ext cx="0" cy="361950"/>
+          </a:xfrm>
+          <a:prstGeom prst="line">
+            <a:avLst/>
+          </a:prstGeom>
+          <a:ln w="28575">
+            <a:solidFill>
+              <a:srgbClr val="7030A0"/>
+            </a:solidFill>
+            <a:prstDash val="dash"/>
+            <a:tailEnd type="triangle"/>
+          </a:ln>
+        </p:spPr>
+        <p:style>
+          <a:lnRef idx="2">
+            <a:schemeClr val="accent1"/>
+          </a:lnRef>
+          <a:fillRef idx="0">
+            <a:schemeClr val="accent1"/>
+          </a:fillRef>
+          <a:effectRef idx="1">
+            <a:schemeClr val="accent1"/>
+          </a:effectRef>
+          <a:fontRef idx="minor">
+            <a:schemeClr val="tx1"/>
+          </a:fontRef>
+        </p:style>
+      </p:cxnSp>
+      <p:sp>
+        <p:nvSpPr>
+          <p:cNvPr id="126" name="TextBox 125"/>
+          <p:cNvSpPr txBox="1"/>
+          <p:nvPr/>
+        </p:nvSpPr>
+        <p:spPr>
+          <a:xfrm>
+            <a:off x="2857500" y="685800"/>
+            <a:ext cx="2095500" cy="285750"/>
+          </a:xfrm>
+          <a:prstGeom prst="rect">
+            <a:avLst/>
+          </a:prstGeom>
+          <a:noFill/>
+        </p:spPr>
+        <p:txBody>
+          <a:bodyPr wrap="none">
+            <a:spAutoFit/>
+          </a:bodyPr>
+          <a:lstStyle/>
+          <a:p>
+            <a:r>
+              <a:rPr sz="1600" i="0"/>
+              <a:t>Total System Cost</a:t>
+            </a:r>
+          </a:p>
+        </p:txBody>
+      </p:sp>
+      <p:cxnSp>
+        <p:nvCxnSpPr>
+          <p:cNvPr id="127" name="Connector 126"/>
+          <p:cNvCxnSpPr/>
+          <p:nvPr/>
+        </p:nvCxnSpPr>
+        <p:spPr>
+          <a:xfrm>
+            <a:off x="8921723" y="5589206"/>
+            <a:ext cx="0" cy="983044"/>
+          </a:xfrm>
+          <a:prstGeom prst="line">
+            <a:avLst/>
+          </a:prstGeom>
+          <a:ln w="28575">
+            <a:solidFill>
+              <a:srgbClr val="ED7D31"/>
+            </a:solidFill>
+          </a:ln>
+        </p:spPr>
+        <p:style>
+          <a:lnRef idx="2">
+            <a:schemeClr val="accent1"/>
+          </a:lnRef>
+          <a:fillRef idx="0">
+            <a:schemeClr val="accent1"/>
+          </a:fillRef>
+          <a:effectRef idx="1">
+            <a:schemeClr val="accent1"/>
+          </a:effectRef>
+          <a:fontRef idx="minor">
+            <a:schemeClr val="tx1"/>
+          </a:fontRef>
+        </p:style>
+      </p:cxnSp>
+      <p:cxnSp>
+        <p:nvCxnSpPr>
+          <p:cNvPr id="128" name="Connector 127"/>
+          <p:cNvCxnSpPr/>
+          <p:nvPr/>
+        </p:nvCxnSpPr>
+        <p:spPr>
+          <a:xfrm flipH="1">
+            <a:off x="400050" y="6572250"/>
+            <a:ext cx="8521673" cy="0"/>
+          </a:xfrm>
+          <a:prstGeom prst="line">
+            <a:avLst/>
+          </a:prstGeom>
+          <a:ln w="28575">
+            <a:solidFill>
+              <a:srgbClr val="ED7D31"/>
+            </a:solidFill>
+          </a:ln>
+        </p:spPr>
+        <p:style>
+          <a:lnRef idx="2">
+            <a:schemeClr val="accent1"/>
+          </a:lnRef>
+          <a:fillRef idx="0">
+            <a:schemeClr val="accent1"/>
+          </a:fillRef>
+          <a:effectRef idx="1">
+            <a:schemeClr val="accent1"/>
+          </a:effectRef>
+          <a:fontRef idx="minor">
+            <a:schemeClr val="tx1"/>
+          </a:fontRef>
+        </p:style>
+      </p:cxnSp>
+      <p:cxnSp>
+        <p:nvCxnSpPr>
+          <p:cNvPr id="129" name="Connector 128"/>
+          <p:cNvCxnSpPr/>
+          <p:nvPr/>
+        </p:nvCxnSpPr>
+        <p:spPr>
+          <a:xfrm flipV="1">
+            <a:off x="400050" y="1905000"/>
+            <a:ext cx="0" cy="4667250"/>
+          </a:xfrm>
+          <a:prstGeom prst="line">
+            <a:avLst/>
+          </a:prstGeom>
+          <a:ln w="28575">
+            <a:solidFill>
+              <a:srgbClr val="ED7D31"/>
+            </a:solidFill>
+          </a:ln>
+        </p:spPr>
+        <p:style>
+          <a:lnRef idx="2">
+            <a:schemeClr val="accent1"/>
+          </a:lnRef>
+          <a:fillRef idx="0">
+            <a:schemeClr val="accent1"/>
+          </a:fillRef>
+          <a:effectRef idx="1">
+            <a:schemeClr val="accent1"/>
+          </a:effectRef>
+          <a:fontRef idx="minor">
+            <a:schemeClr val="tx1"/>
+          </a:fontRef>
+        </p:style>
+      </p:cxnSp>
+      <p:cxnSp>
+        <p:nvCxnSpPr>
+          <p:cNvPr id="130" name="Connector 129"/>
+          <p:cNvCxnSpPr/>
+          <p:nvPr/>
+        </p:nvCxnSpPr>
+        <p:spPr>
+          <a:xfrm>
+            <a:off x="400050" y="1978519"/>
+            <a:ext cx="254451" cy="0"/>
+          </a:xfrm>
+          <a:prstGeom prst="line">
+            <a:avLst/>
+          </a:prstGeom>
+          <a:ln w="28575">
+            <a:solidFill>
+              <a:srgbClr val="ED7D31"/>
+            </a:solidFill>
+            <a:tailEnd type="triangle"/>
+          </a:ln>
+        </p:spPr>
+        <p:style>
+          <a:lnRef idx="2">
+            <a:schemeClr val="accent1"/>
+          </a:lnRef>
+          <a:fillRef idx="0">
+            <a:schemeClr val="accent1"/>
+          </a:fillRef>
+          <a:effectRef idx="1">
+            <a:schemeClr val="accent1"/>
+          </a:effectRef>
+          <a:fontRef idx="minor">
+            <a:schemeClr val="tx1"/>
+          </a:fontRef>
+        </p:style>
+      </p:cxnSp>
+      <p:cxnSp>
+        <p:nvCxnSpPr>
+          <p:cNvPr id="131" name="Connector 130"/>
+          <p:cNvCxnSpPr/>
+          <p:nvPr/>
+        </p:nvCxnSpPr>
+        <p:spPr>
+          <a:xfrm>
+            <a:off x="400050" y="3257493"/>
+            <a:ext cx="254620" cy="0"/>
+          </a:xfrm>
+          <a:prstGeom prst="line">
+            <a:avLst/>
+          </a:prstGeom>
+          <a:ln w="28575">
+            <a:solidFill>
+              <a:srgbClr val="ED7D31"/>
+            </a:solidFill>
+            <a:tailEnd type="triangle"/>
+          </a:ln>
+        </p:spPr>
+        <p:style>
+          <a:lnRef idx="2">
+            <a:schemeClr val="accent1"/>
+          </a:lnRef>
+          <a:fillRef idx="0">
+            <a:schemeClr val="accent1"/>
+          </a:fillRef>
+          <a:effectRef idx="1">
+            <a:schemeClr val="accent1"/>
+          </a:effectRef>
+          <a:fontRef idx="minor">
+            <a:schemeClr val="tx1"/>
+          </a:fontRef>
+        </p:style>
+      </p:cxnSp>
+      <p:cxnSp>
+        <p:nvCxnSpPr>
+          <p:cNvPr id="132" name="Connector 131"/>
+          <p:cNvCxnSpPr/>
+          <p:nvPr/>
+        </p:nvCxnSpPr>
+        <p:spPr>
+          <a:xfrm>
+            <a:off x="400050" y="4621889"/>
+            <a:ext cx="254121" cy="0"/>
+          </a:xfrm>
+          <a:prstGeom prst="line">
+            <a:avLst/>
+          </a:prstGeom>
+          <a:ln w="28575">
+            <a:solidFill>
+              <a:srgbClr val="ED7D31"/>
+            </a:solidFill>
+            <a:tailEnd type="triangle"/>
+          </a:ln>
+        </p:spPr>
+        <p:style>
+          <a:lnRef idx="2">
+            <a:schemeClr val="accent1"/>
+          </a:lnRef>
+          <a:fillRef idx="0">
+            <a:schemeClr val="accent1"/>
+          </a:fillRef>
+          <a:effectRef idx="1">
+            <a:schemeClr val="accent1"/>
+          </a:effectRef>
+          <a:fontRef idx="minor">
+            <a:schemeClr val="tx1"/>
+          </a:fontRef>
+        </p:style>
+      </p:cxnSp>
+      <p:sp>
+        <p:nvSpPr>
+          <p:cNvPr id="133" name="TextBox 132"/>
+          <p:cNvSpPr txBox="1"/>
+          <p:nvPr/>
+        </p:nvSpPr>
+        <p:spPr>
+          <a:xfrm>
+            <a:off x="4152900" y="6591300"/>
+            <a:ext cx="4000500" cy="285750"/>
+          </a:xfrm>
+          <a:prstGeom prst="rect">
+            <a:avLst/>
+          </a:prstGeom>
+          <a:noFill/>
+        </p:spPr>
+        <p:txBody>
+          <a:bodyPr wrap="none">
+            <a:spAutoFit/>
+          </a:bodyPr>
+          <a:lstStyle/>
+          <a:p>
+            <a:r>
+              <a:rPr sz="1300" i="0">
+                <a:solidFill>
+                  <a:srgbClr val="ED7D31"/>
+                </a:solidFill>
+              </a:rPr>
+              <a:t>Land-use inputs, e.g. N fertilizer, agricultural energy</a:t>
             </a:r>
           </a:p>
         </p:txBody>

</xml_diff>